<commit_message>
Update opening defense materials
</commit_message>
<xml_diff>
--- a/docs/opening/opening_ppt_template_version_v6_long_notes.pptx
+++ b/docs/opening/opening_ppt_template_version_v6_long_notes.pptx
@@ -58,7 +58,7 @@
         <a:solidFill>
           <a:srgbClr val="FF3300"/>
         </a:solidFill>
-        <a:latin typeface="Arial" panose="020B0604020202020204" pitchFamily="34" charset="0"/>
+        <a:latin typeface="Arial" panose="020B0604020202090204" pitchFamily="34" charset="0"/>
         <a:ea typeface="黑体" panose="02010609060101010101" pitchFamily="49" charset="-122"/>
         <a:cs typeface="+mn-cs"/>
       </a:defRPr>
@@ -78,7 +78,7 @@
         <a:solidFill>
           <a:srgbClr val="FF3300"/>
         </a:solidFill>
-        <a:latin typeface="Arial" panose="020B0604020202020204" pitchFamily="34" charset="0"/>
+        <a:latin typeface="Arial" panose="020B0604020202090204" pitchFamily="34" charset="0"/>
         <a:ea typeface="黑体" panose="02010609060101010101" pitchFamily="49" charset="-122"/>
         <a:cs typeface="+mn-cs"/>
       </a:defRPr>
@@ -98,7 +98,7 @@
         <a:solidFill>
           <a:srgbClr val="FF3300"/>
         </a:solidFill>
-        <a:latin typeface="Arial" panose="020B0604020202020204" pitchFamily="34" charset="0"/>
+        <a:latin typeface="Arial" panose="020B0604020202090204" pitchFamily="34" charset="0"/>
         <a:ea typeface="黑体" panose="02010609060101010101" pitchFamily="49" charset="-122"/>
         <a:cs typeface="+mn-cs"/>
       </a:defRPr>
@@ -118,7 +118,7 @@
         <a:solidFill>
           <a:srgbClr val="FF3300"/>
         </a:solidFill>
-        <a:latin typeface="Arial" panose="020B0604020202020204" pitchFamily="34" charset="0"/>
+        <a:latin typeface="Arial" panose="020B0604020202090204" pitchFamily="34" charset="0"/>
         <a:ea typeface="黑体" panose="02010609060101010101" pitchFamily="49" charset="-122"/>
         <a:cs typeface="+mn-cs"/>
       </a:defRPr>
@@ -138,7 +138,7 @@
         <a:solidFill>
           <a:srgbClr val="FF3300"/>
         </a:solidFill>
-        <a:latin typeface="Arial" panose="020B0604020202020204" pitchFamily="34" charset="0"/>
+        <a:latin typeface="Arial" panose="020B0604020202090204" pitchFamily="34" charset="0"/>
         <a:ea typeface="黑体" panose="02010609060101010101" pitchFamily="49" charset="-122"/>
         <a:cs typeface="+mn-cs"/>
       </a:defRPr>
@@ -158,7 +158,7 @@
         <a:solidFill>
           <a:srgbClr val="FF3300"/>
         </a:solidFill>
-        <a:latin typeface="Arial" panose="020B0604020202020204" pitchFamily="34" charset="0"/>
+        <a:latin typeface="Arial" panose="020B0604020202090204" pitchFamily="34" charset="0"/>
         <a:ea typeface="黑体" panose="02010609060101010101" pitchFamily="49" charset="-122"/>
         <a:cs typeface="+mn-cs"/>
       </a:defRPr>
@@ -178,7 +178,7 @@
         <a:solidFill>
           <a:srgbClr val="FF3300"/>
         </a:solidFill>
-        <a:latin typeface="Arial" panose="020B0604020202020204" pitchFamily="34" charset="0"/>
+        <a:latin typeface="Arial" panose="020B0604020202090204" pitchFamily="34" charset="0"/>
         <a:ea typeface="黑体" panose="02010609060101010101" pitchFamily="49" charset="-122"/>
         <a:cs typeface="+mn-cs"/>
       </a:defRPr>
@@ -198,7 +198,7 @@
         <a:solidFill>
           <a:srgbClr val="FF3300"/>
         </a:solidFill>
-        <a:latin typeface="Arial" panose="020B0604020202020204" pitchFamily="34" charset="0"/>
+        <a:latin typeface="Arial" panose="020B0604020202090204" pitchFamily="34" charset="0"/>
         <a:ea typeface="黑体" panose="02010609060101010101" pitchFamily="49" charset="-122"/>
         <a:cs typeface="+mn-cs"/>
       </a:defRPr>
@@ -218,7 +218,7 @@
         <a:solidFill>
           <a:srgbClr val="FF3300"/>
         </a:solidFill>
-        <a:latin typeface="Arial" panose="020B0604020202020204" pitchFamily="34" charset="0"/>
+        <a:latin typeface="Arial" panose="020B0604020202090204" pitchFamily="34" charset="0"/>
         <a:ea typeface="黑体" panose="02010609060101010101" pitchFamily="49" charset="-122"/>
         <a:cs typeface="+mn-cs"/>
       </a:defRPr>
@@ -338,7 +338,7 @@
                 <a:solidFill>
                   <a:schemeClr val="tx1"/>
                 </a:solidFill>
-                <a:ea typeface="宋体" panose="02010600030101010101" pitchFamily="2" charset="-122"/>
+                <a:ea typeface="宋体" pitchFamily="2" charset="-122"/>
               </a:defRPr>
             </a:lvl1pPr>
           </a:lstStyle>
@@ -369,8 +369,8 @@
               <a:effectLst/>
               <a:uLnTx/>
               <a:uFillTx/>
-              <a:latin typeface="Arial" panose="020B0604020202020204" pitchFamily="34" charset="0"/>
-              <a:ea typeface="宋体" panose="02010600030101010101" pitchFamily="2" charset="-122"/>
+              <a:latin typeface="Arial" panose="020B0604020202090204" pitchFamily="34" charset="0"/>
+              <a:ea typeface="宋体" pitchFamily="2" charset="-122"/>
               <a:cs typeface="+mn-cs"/>
             </a:endParaRPr>
           </a:p>
@@ -446,7 +446,7 @@
                 <a:solidFill>
                   <a:schemeClr val="tx1"/>
                 </a:solidFill>
-                <a:ea typeface="宋体" panose="02010600030101010101" pitchFamily="2" charset="-122"/>
+                <a:ea typeface="宋体" pitchFamily="2" charset="-122"/>
               </a:defRPr>
             </a:lvl1pPr>
           </a:lstStyle>
@@ -477,8 +477,8 @@
               <a:effectLst/>
               <a:uLnTx/>
               <a:uFillTx/>
-              <a:latin typeface="Arial" panose="020B0604020202020204" pitchFamily="34" charset="0"/>
-              <a:ea typeface="宋体" panose="02010600030101010101" pitchFamily="2" charset="-122"/>
+              <a:latin typeface="Arial" panose="020B0604020202090204" pitchFamily="34" charset="0"/>
+              <a:ea typeface="宋体" pitchFamily="2" charset="-122"/>
               <a:cs typeface="+mn-cs"/>
             </a:endParaRPr>
           </a:p>
@@ -554,7 +554,7 @@
                 <a:solidFill>
                   <a:schemeClr val="tx1"/>
                 </a:solidFill>
-                <a:ea typeface="宋体" panose="02010600030101010101" pitchFamily="2" charset="-122"/>
+                <a:ea typeface="宋体" pitchFamily="2" charset="-122"/>
               </a:defRPr>
             </a:lvl1pPr>
           </a:lstStyle>
@@ -585,8 +585,8 @@
               <a:effectLst/>
               <a:uLnTx/>
               <a:uFillTx/>
-              <a:latin typeface="Arial" panose="020B0604020202020204" pitchFamily="34" charset="0"/>
-              <a:ea typeface="宋体" panose="02010600030101010101" pitchFamily="2" charset="-122"/>
+              <a:latin typeface="Arial" panose="020B0604020202090204" pitchFamily="34" charset="0"/>
+              <a:ea typeface="宋体" pitchFamily="2" charset="-122"/>
               <a:cs typeface="+mn-cs"/>
             </a:endParaRPr>
           </a:p>
@@ -662,7 +662,7 @@
                 <a:solidFill>
                   <a:schemeClr val="tx1"/>
                 </a:solidFill>
-                <a:ea typeface="宋体" panose="02010600030101010101" pitchFamily="2" charset="-122"/>
+                <a:ea typeface="宋体" pitchFamily="2" charset="-122"/>
               </a:defRPr>
             </a:lvl1pPr>
           </a:lstStyle>
@@ -694,8 +694,8 @@
                 <a:effectLst/>
                 <a:uLnTx/>
                 <a:uFillTx/>
-                <a:latin typeface="Arial" panose="020B0604020202020204" pitchFamily="34" charset="0"/>
-                <a:ea typeface="宋体" panose="02010600030101010101" pitchFamily="2" charset="-122"/>
+                <a:latin typeface="Arial" panose="020B0604020202090204" pitchFamily="34" charset="0"/>
+                <a:ea typeface="宋体" pitchFamily="2" charset="-122"/>
                 <a:cs typeface="+mn-cs"/>
               </a:rPr>
             </a:fld>
@@ -709,8 +709,8 @@
               <a:effectLst/>
               <a:uLnTx/>
               <a:uFillTx/>
-              <a:latin typeface="Arial" panose="020B0604020202020204" pitchFamily="34" charset="0"/>
-              <a:ea typeface="宋体" panose="02010600030101010101" pitchFamily="2" charset="-122"/>
+              <a:latin typeface="Arial" panose="020B0604020202090204" pitchFamily="34" charset="0"/>
+              <a:ea typeface="宋体" pitchFamily="2" charset="-122"/>
               <a:cs typeface="+mn-cs"/>
             </a:endParaRPr>
           </a:p>
@@ -817,7 +817,7 @@
                 <a:solidFill>
                   <a:schemeClr val="tx1"/>
                 </a:solidFill>
-                <a:ea typeface="宋体" panose="02010600030101010101" pitchFamily="2" charset="-122"/>
+                <a:ea typeface="宋体" pitchFamily="2" charset="-122"/>
               </a:defRPr>
             </a:lvl1pPr>
           </a:lstStyle>
@@ -848,8 +848,8 @@
               <a:effectLst/>
               <a:uLnTx/>
               <a:uFillTx/>
-              <a:latin typeface="Arial" panose="020B0604020202020204" pitchFamily="34" charset="0"/>
-              <a:ea typeface="宋体" panose="02010600030101010101" pitchFamily="2" charset="-122"/>
+              <a:latin typeface="Arial" panose="020B0604020202090204" pitchFamily="34" charset="0"/>
+              <a:ea typeface="宋体" pitchFamily="2" charset="-122"/>
               <a:cs typeface="+mn-cs"/>
             </a:endParaRPr>
           </a:p>
@@ -925,7 +925,7 @@
                 <a:solidFill>
                   <a:schemeClr val="tx1"/>
                 </a:solidFill>
-                <a:ea typeface="宋体" panose="02010600030101010101" pitchFamily="2" charset="-122"/>
+                <a:ea typeface="宋体" pitchFamily="2" charset="-122"/>
               </a:defRPr>
             </a:lvl1pPr>
           </a:lstStyle>
@@ -956,8 +956,8 @@
               <a:effectLst/>
               <a:uLnTx/>
               <a:uFillTx/>
-              <a:latin typeface="Arial" panose="020B0604020202020204" pitchFamily="34" charset="0"/>
-              <a:ea typeface="宋体" panose="02010600030101010101" pitchFamily="2" charset="-122"/>
+              <a:latin typeface="Arial" panose="020B0604020202090204" pitchFamily="34" charset="0"/>
+              <a:ea typeface="宋体" pitchFamily="2" charset="-122"/>
               <a:cs typeface="+mn-cs"/>
             </a:endParaRPr>
           </a:p>
@@ -1076,8 +1076,8 @@
                 <a:effectLst/>
                 <a:uLnTx/>
                 <a:uFillTx/>
-                <a:latin typeface="Arial" panose="020B0604020202020204" pitchFamily="34" charset="0"/>
-                <a:ea typeface="宋体" panose="02010600030101010101" pitchFamily="2" charset="-122"/>
+                <a:latin typeface="Arial" panose="020B0604020202090204" pitchFamily="34" charset="0"/>
+                <a:ea typeface="宋体" pitchFamily="2" charset="-122"/>
                 <a:cs typeface="+mn-cs"/>
               </a:rPr>
               <a:t>单击此处编辑母版文本样式</a:t>
@@ -1092,8 +1092,8 @@
               <a:effectLst/>
               <a:uLnTx/>
               <a:uFillTx/>
-              <a:latin typeface="Arial" panose="020B0604020202020204" pitchFamily="34" charset="0"/>
-              <a:ea typeface="宋体" panose="02010600030101010101" pitchFamily="2" charset="-122"/>
+              <a:latin typeface="Arial" panose="020B0604020202090204" pitchFamily="34" charset="0"/>
+              <a:ea typeface="宋体" pitchFamily="2" charset="-122"/>
               <a:cs typeface="+mn-cs"/>
             </a:endParaRPr>
           </a:p>
@@ -1125,8 +1125,8 @@
                 <a:effectLst/>
                 <a:uLnTx/>
                 <a:uFillTx/>
-                <a:latin typeface="Arial" panose="020B0604020202020204" pitchFamily="34" charset="0"/>
-                <a:ea typeface="宋体" panose="02010600030101010101" pitchFamily="2" charset="-122"/>
+                <a:latin typeface="Arial" panose="020B0604020202090204" pitchFamily="34" charset="0"/>
+                <a:ea typeface="宋体" pitchFamily="2" charset="-122"/>
                 <a:cs typeface="+mn-cs"/>
               </a:rPr>
               <a:t>第二级</a:t>
@@ -1141,8 +1141,8 @@
               <a:effectLst/>
               <a:uLnTx/>
               <a:uFillTx/>
-              <a:latin typeface="Arial" panose="020B0604020202020204" pitchFamily="34" charset="0"/>
-              <a:ea typeface="宋体" panose="02010600030101010101" pitchFamily="2" charset="-122"/>
+              <a:latin typeface="Arial" panose="020B0604020202090204" pitchFamily="34" charset="0"/>
+              <a:ea typeface="宋体" pitchFamily="2" charset="-122"/>
               <a:cs typeface="+mn-cs"/>
             </a:endParaRPr>
           </a:p>
@@ -1174,8 +1174,8 @@
                 <a:effectLst/>
                 <a:uLnTx/>
                 <a:uFillTx/>
-                <a:latin typeface="Arial" panose="020B0604020202020204" pitchFamily="34" charset="0"/>
-                <a:ea typeface="宋体" panose="02010600030101010101" pitchFamily="2" charset="-122"/>
+                <a:latin typeface="Arial" panose="020B0604020202090204" pitchFamily="34" charset="0"/>
+                <a:ea typeface="宋体" pitchFamily="2" charset="-122"/>
                 <a:cs typeface="+mn-cs"/>
               </a:rPr>
               <a:t>第三级</a:t>
@@ -1190,8 +1190,8 @@
               <a:effectLst/>
               <a:uLnTx/>
               <a:uFillTx/>
-              <a:latin typeface="Arial" panose="020B0604020202020204" pitchFamily="34" charset="0"/>
-              <a:ea typeface="宋体" panose="02010600030101010101" pitchFamily="2" charset="-122"/>
+              <a:latin typeface="Arial" panose="020B0604020202090204" pitchFamily="34" charset="0"/>
+              <a:ea typeface="宋体" pitchFamily="2" charset="-122"/>
               <a:cs typeface="+mn-cs"/>
             </a:endParaRPr>
           </a:p>
@@ -1223,8 +1223,8 @@
                 <a:effectLst/>
                 <a:uLnTx/>
                 <a:uFillTx/>
-                <a:latin typeface="Arial" panose="020B0604020202020204" pitchFamily="34" charset="0"/>
-                <a:ea typeface="宋体" panose="02010600030101010101" pitchFamily="2" charset="-122"/>
+                <a:latin typeface="Arial" panose="020B0604020202090204" pitchFamily="34" charset="0"/>
+                <a:ea typeface="宋体" pitchFamily="2" charset="-122"/>
                 <a:cs typeface="+mn-cs"/>
               </a:rPr>
               <a:t>第四级</a:t>
@@ -1239,8 +1239,8 @@
               <a:effectLst/>
               <a:uLnTx/>
               <a:uFillTx/>
-              <a:latin typeface="Arial" panose="020B0604020202020204" pitchFamily="34" charset="0"/>
-              <a:ea typeface="宋体" panose="02010600030101010101" pitchFamily="2" charset="-122"/>
+              <a:latin typeface="Arial" panose="020B0604020202090204" pitchFamily="34" charset="0"/>
+              <a:ea typeface="宋体" pitchFamily="2" charset="-122"/>
               <a:cs typeface="+mn-cs"/>
             </a:endParaRPr>
           </a:p>
@@ -1272,8 +1272,8 @@
                 <a:effectLst/>
                 <a:uLnTx/>
                 <a:uFillTx/>
-                <a:latin typeface="Arial" panose="020B0604020202020204" pitchFamily="34" charset="0"/>
-                <a:ea typeface="宋体" panose="02010600030101010101" pitchFamily="2" charset="-122"/>
+                <a:latin typeface="Arial" panose="020B0604020202090204" pitchFamily="34" charset="0"/>
+                <a:ea typeface="宋体" pitchFamily="2" charset="-122"/>
                 <a:cs typeface="+mn-cs"/>
               </a:rPr>
               <a:t>第五级</a:t>
@@ -1288,8 +1288,8 @@
               <a:effectLst/>
               <a:uLnTx/>
               <a:uFillTx/>
-              <a:latin typeface="Arial" panose="020B0604020202020204" pitchFamily="34" charset="0"/>
-              <a:ea typeface="宋体" panose="02010600030101010101" pitchFamily="2" charset="-122"/>
+              <a:latin typeface="Arial" panose="020B0604020202090204" pitchFamily="34" charset="0"/>
+              <a:ea typeface="宋体" pitchFamily="2" charset="-122"/>
               <a:cs typeface="+mn-cs"/>
             </a:endParaRPr>
           </a:p>
@@ -1365,7 +1365,7 @@
                 <a:solidFill>
                   <a:schemeClr val="tx1"/>
                 </a:solidFill>
-                <a:ea typeface="宋体" panose="02010600030101010101" pitchFamily="2" charset="-122"/>
+                <a:ea typeface="宋体" pitchFamily="2" charset="-122"/>
               </a:defRPr>
             </a:lvl1pPr>
           </a:lstStyle>
@@ -1396,8 +1396,8 @@
               <a:effectLst/>
               <a:uLnTx/>
               <a:uFillTx/>
-              <a:latin typeface="Arial" panose="020B0604020202020204" pitchFamily="34" charset="0"/>
-              <a:ea typeface="宋体" panose="02010600030101010101" pitchFamily="2" charset="-122"/>
+              <a:latin typeface="Arial" panose="020B0604020202090204" pitchFamily="34" charset="0"/>
+              <a:ea typeface="宋体" pitchFamily="2" charset="-122"/>
               <a:cs typeface="+mn-cs"/>
             </a:endParaRPr>
           </a:p>
@@ -1473,7 +1473,7 @@
                 <a:solidFill>
                   <a:schemeClr val="tx1"/>
                 </a:solidFill>
-                <a:ea typeface="宋体" panose="02010600030101010101" pitchFamily="2" charset="-122"/>
+                <a:ea typeface="宋体" pitchFamily="2" charset="-122"/>
               </a:defRPr>
             </a:lvl1pPr>
           </a:lstStyle>
@@ -1505,8 +1505,8 @@
                 <a:effectLst/>
                 <a:uLnTx/>
                 <a:uFillTx/>
-                <a:latin typeface="Arial" panose="020B0604020202020204" pitchFamily="34" charset="0"/>
-                <a:ea typeface="宋体" panose="02010600030101010101" pitchFamily="2" charset="-122"/>
+                <a:latin typeface="Arial" panose="020B0604020202090204" pitchFamily="34" charset="0"/>
+                <a:ea typeface="宋体" pitchFamily="2" charset="-122"/>
                 <a:cs typeface="+mn-cs"/>
               </a:rPr>
             </a:fld>
@@ -1520,8 +1520,8 @@
               <a:effectLst/>
               <a:uLnTx/>
               <a:uFillTx/>
-              <a:latin typeface="Arial" panose="020B0604020202020204" pitchFamily="34" charset="0"/>
-              <a:ea typeface="宋体" panose="02010600030101010101" pitchFamily="2" charset="-122"/>
+              <a:latin typeface="Arial" panose="020B0604020202090204" pitchFamily="34" charset="0"/>
+              <a:ea typeface="宋体" pitchFamily="2" charset="-122"/>
               <a:cs typeface="+mn-cs"/>
             </a:endParaRPr>
           </a:p>
@@ -1543,8 +1543,8 @@
         <a:solidFill>
           <a:schemeClr val="tx1"/>
         </a:solidFill>
-        <a:latin typeface="Arial" panose="020B0604020202020204" pitchFamily="34" charset="0"/>
-        <a:ea typeface="宋体" panose="02010600030101010101" pitchFamily="2" charset="-122"/>
+        <a:latin typeface="Arial" panose="020B0604020202090204" pitchFamily="34" charset="0"/>
+        <a:ea typeface="宋体" pitchFamily="2" charset="-122"/>
         <a:cs typeface="+mn-cs"/>
       </a:defRPr>
     </a:lvl1pPr>
@@ -1559,8 +1559,8 @@
         <a:solidFill>
           <a:schemeClr val="tx1"/>
         </a:solidFill>
-        <a:latin typeface="Arial" panose="020B0604020202020204" pitchFamily="34" charset="0"/>
-        <a:ea typeface="宋体" panose="02010600030101010101" pitchFamily="2" charset="-122"/>
+        <a:latin typeface="Arial" panose="020B0604020202090204" pitchFamily="34" charset="0"/>
+        <a:ea typeface="宋体" pitchFamily="2" charset="-122"/>
         <a:cs typeface="+mn-cs"/>
       </a:defRPr>
     </a:lvl2pPr>
@@ -1575,8 +1575,8 @@
         <a:solidFill>
           <a:schemeClr val="tx1"/>
         </a:solidFill>
-        <a:latin typeface="Arial" panose="020B0604020202020204" pitchFamily="34" charset="0"/>
-        <a:ea typeface="宋体" panose="02010600030101010101" pitchFamily="2" charset="-122"/>
+        <a:latin typeface="Arial" panose="020B0604020202090204" pitchFamily="34" charset="0"/>
+        <a:ea typeface="宋体" pitchFamily="2" charset="-122"/>
         <a:cs typeface="+mn-cs"/>
       </a:defRPr>
     </a:lvl3pPr>
@@ -1591,8 +1591,8 @@
         <a:solidFill>
           <a:schemeClr val="tx1"/>
         </a:solidFill>
-        <a:latin typeface="Arial" panose="020B0604020202020204" pitchFamily="34" charset="0"/>
-        <a:ea typeface="宋体" panose="02010600030101010101" pitchFamily="2" charset="-122"/>
+        <a:latin typeface="Arial" panose="020B0604020202090204" pitchFamily="34" charset="0"/>
+        <a:ea typeface="宋体" pitchFamily="2" charset="-122"/>
         <a:cs typeface="+mn-cs"/>
       </a:defRPr>
     </a:lvl4pPr>
@@ -1607,8 +1607,8 @@
         <a:solidFill>
           <a:schemeClr val="tx1"/>
         </a:solidFill>
-        <a:latin typeface="Arial" panose="020B0604020202020204" pitchFamily="34" charset="0"/>
-        <a:ea typeface="宋体" panose="02010600030101010101" pitchFamily="2" charset="-122"/>
+        <a:latin typeface="Arial" panose="020B0604020202090204" pitchFamily="34" charset="0"/>
+        <a:ea typeface="宋体" pitchFamily="2" charset="-122"/>
         <a:cs typeface="+mn-cs"/>
       </a:defRPr>
     </a:lvl5pPr>
@@ -4181,7 +4181,7 @@
                 <a:solidFill>
                   <a:srgbClr val="FF3300"/>
                 </a:solidFill>
-                <a:latin typeface="Arial" panose="020B0604020202020204" pitchFamily="34" charset="0"/>
+                <a:latin typeface="Arial" panose="020B0604020202090204" pitchFamily="34" charset="0"/>
                 <a:ea typeface="黑体" panose="02010609060101010101" pitchFamily="49" charset="-122"/>
               </a:defRPr>
             </a:lvl1pPr>
@@ -4201,7 +4201,7 @@
                 <a:solidFill>
                   <a:srgbClr val="FF3300"/>
                 </a:solidFill>
-                <a:latin typeface="Arial" panose="020B0604020202020204" pitchFamily="34" charset="0"/>
+                <a:latin typeface="Arial" panose="020B0604020202090204" pitchFamily="34" charset="0"/>
                 <a:ea typeface="黑体" panose="02010609060101010101" pitchFamily="49" charset="-122"/>
               </a:defRPr>
             </a:lvl2pPr>
@@ -4221,7 +4221,7 @@
                 <a:solidFill>
                   <a:srgbClr val="FF3300"/>
                 </a:solidFill>
-                <a:latin typeface="Arial" panose="020B0604020202020204" pitchFamily="34" charset="0"/>
+                <a:latin typeface="Arial" panose="020B0604020202090204" pitchFamily="34" charset="0"/>
                 <a:ea typeface="黑体" panose="02010609060101010101" pitchFamily="49" charset="-122"/>
               </a:defRPr>
             </a:lvl3pPr>
@@ -4241,7 +4241,7 @@
                 <a:solidFill>
                   <a:srgbClr val="FF3300"/>
                 </a:solidFill>
-                <a:latin typeface="Arial" panose="020B0604020202020204" pitchFamily="34" charset="0"/>
+                <a:latin typeface="Arial" panose="020B0604020202090204" pitchFamily="34" charset="0"/>
                 <a:ea typeface="黑体" panose="02010609060101010101" pitchFamily="49" charset="-122"/>
               </a:defRPr>
             </a:lvl4pPr>
@@ -4261,7 +4261,7 @@
                 <a:solidFill>
                   <a:srgbClr val="FF3300"/>
                 </a:solidFill>
-                <a:latin typeface="Arial" panose="020B0604020202020204" pitchFamily="34" charset="0"/>
+                <a:latin typeface="Arial" panose="020B0604020202090204" pitchFamily="34" charset="0"/>
                 <a:ea typeface="黑体" panose="02010609060101010101" pitchFamily="49" charset="-122"/>
               </a:defRPr>
             </a:lvl5pPr>
@@ -4284,7 +4284,7 @@
                 <a:solidFill>
                   <a:srgbClr val="FF3300"/>
                 </a:solidFill>
-                <a:latin typeface="Arial" panose="020B0604020202020204" pitchFamily="34" charset="0"/>
+                <a:latin typeface="Arial" panose="020B0604020202090204" pitchFamily="34" charset="0"/>
                 <a:ea typeface="黑体" panose="02010609060101010101" pitchFamily="49" charset="-122"/>
               </a:defRPr>
             </a:lvl6pPr>
@@ -4307,7 +4307,7 @@
                 <a:solidFill>
                   <a:srgbClr val="FF3300"/>
                 </a:solidFill>
-                <a:latin typeface="Arial" panose="020B0604020202020204" pitchFamily="34" charset="0"/>
+                <a:latin typeface="Arial" panose="020B0604020202090204" pitchFamily="34" charset="0"/>
                 <a:ea typeface="黑体" panose="02010609060101010101" pitchFamily="49" charset="-122"/>
               </a:defRPr>
             </a:lvl7pPr>
@@ -4330,7 +4330,7 @@
                 <a:solidFill>
                   <a:srgbClr val="FF3300"/>
                 </a:solidFill>
-                <a:latin typeface="Arial" panose="020B0604020202020204" pitchFamily="34" charset="0"/>
+                <a:latin typeface="Arial" panose="020B0604020202090204" pitchFamily="34" charset="0"/>
                 <a:ea typeface="黑体" panose="02010609060101010101" pitchFamily="49" charset="-122"/>
               </a:defRPr>
             </a:lvl8pPr>
@@ -4353,7 +4353,7 @@
                 <a:solidFill>
                   <a:srgbClr val="FF3300"/>
                 </a:solidFill>
-                <a:latin typeface="Arial" panose="020B0604020202020204" pitchFamily="34" charset="0"/>
+                <a:latin typeface="Arial" panose="020B0604020202090204" pitchFamily="34" charset="0"/>
                 <a:ea typeface="黑体" panose="02010609060101010101" pitchFamily="49" charset="-122"/>
               </a:defRPr>
             </a:lvl9pPr>
@@ -4387,7 +4387,7 @@
               <a:effectLst/>
               <a:uLnTx/>
               <a:uFillTx/>
-              <a:latin typeface="Arial" panose="020B0604020202020204" pitchFamily="34" charset="0"/>
+              <a:latin typeface="Arial" panose="020B0604020202090204" pitchFamily="34" charset="0"/>
               <a:ea typeface="黑体" panose="02010609060101010101" pitchFamily="49" charset="-122"/>
               <a:cs typeface="+mn-cs"/>
             </a:endParaRPr>
@@ -4539,8 +4539,8 @@
               <a:effectLst/>
               <a:uLnTx/>
               <a:uFillTx/>
-              <a:latin typeface="Arial" panose="020B0604020202020204" pitchFamily="34" charset="0"/>
-              <a:ea typeface="宋体" panose="02010600030101010101" pitchFamily="2" charset="-122"/>
+              <a:latin typeface="Arial" panose="020B0604020202090204" pitchFamily="34" charset="0"/>
+              <a:ea typeface="宋体" pitchFamily="2" charset="-122"/>
               <a:cs typeface="+mn-cs"/>
             </a:endParaRPr>
           </a:p>
@@ -4623,8 +4623,8 @@
               <a:effectLst/>
               <a:uLnTx/>
               <a:uFillTx/>
-              <a:latin typeface="Arial" panose="020B0604020202020204" pitchFamily="34" charset="0"/>
-              <a:ea typeface="宋体" panose="02010600030101010101" pitchFamily="2" charset="-122"/>
+              <a:latin typeface="Arial" panose="020B0604020202090204" pitchFamily="34" charset="0"/>
+              <a:ea typeface="宋体" pitchFamily="2" charset="-122"/>
               <a:cs typeface="+mn-cs"/>
             </a:endParaRPr>
           </a:p>
@@ -4708,8 +4708,8 @@
                 <a:effectLst/>
                 <a:uLnTx/>
                 <a:uFillTx/>
-                <a:latin typeface="Arial" panose="020B0604020202020204" pitchFamily="34" charset="0"/>
-                <a:ea typeface="宋体" panose="02010600030101010101" pitchFamily="2" charset="-122"/>
+                <a:latin typeface="Arial" panose="020B0604020202090204" pitchFamily="34" charset="0"/>
+                <a:ea typeface="宋体" pitchFamily="2" charset="-122"/>
                 <a:cs typeface="+mn-cs"/>
               </a:rPr>
             </a:fld>
@@ -4723,8 +4723,8 @@
               <a:effectLst/>
               <a:uLnTx/>
               <a:uFillTx/>
-              <a:latin typeface="Arial" panose="020B0604020202020204" pitchFamily="34" charset="0"/>
-              <a:ea typeface="宋体" panose="02010600030101010101" pitchFamily="2" charset="-122"/>
+              <a:latin typeface="Arial" panose="020B0604020202090204" pitchFamily="34" charset="0"/>
+              <a:ea typeface="宋体" pitchFamily="2" charset="-122"/>
               <a:cs typeface="+mn-cs"/>
             </a:endParaRPr>
           </a:p>
@@ -4879,8 +4879,8 @@
               <a:effectLst/>
               <a:uLnTx/>
               <a:uFillTx/>
-              <a:latin typeface="Arial" panose="020B0604020202020204" pitchFamily="34" charset="0"/>
-              <a:ea typeface="宋体" panose="02010600030101010101" pitchFamily="2" charset="-122"/>
+              <a:latin typeface="Arial" panose="020B0604020202090204" pitchFamily="34" charset="0"/>
+              <a:ea typeface="宋体" pitchFamily="2" charset="-122"/>
               <a:cs typeface="+mn-cs"/>
             </a:endParaRPr>
           </a:p>
@@ -4927,8 +4927,8 @@
               <a:effectLst/>
               <a:uLnTx/>
               <a:uFillTx/>
-              <a:latin typeface="Arial" panose="020B0604020202020204" pitchFamily="34" charset="0"/>
-              <a:ea typeface="宋体" panose="02010600030101010101" pitchFamily="2" charset="-122"/>
+              <a:latin typeface="Arial" panose="020B0604020202090204" pitchFamily="34" charset="0"/>
+              <a:ea typeface="宋体" pitchFamily="2" charset="-122"/>
               <a:cs typeface="+mn-cs"/>
             </a:endParaRPr>
           </a:p>
@@ -4976,8 +4976,8 @@
                 <a:effectLst/>
                 <a:uLnTx/>
                 <a:uFillTx/>
-                <a:latin typeface="Arial" panose="020B0604020202020204" pitchFamily="34" charset="0"/>
-                <a:ea typeface="宋体" panose="02010600030101010101" pitchFamily="2" charset="-122"/>
+                <a:latin typeface="Arial" panose="020B0604020202090204" pitchFamily="34" charset="0"/>
+                <a:ea typeface="宋体" pitchFamily="2" charset="-122"/>
                 <a:cs typeface="+mn-cs"/>
               </a:rPr>
             </a:fld>
@@ -4991,8 +4991,8 @@
               <a:effectLst/>
               <a:uLnTx/>
               <a:uFillTx/>
-              <a:latin typeface="Arial" panose="020B0604020202020204" pitchFamily="34" charset="0"/>
-              <a:ea typeface="宋体" panose="02010600030101010101" pitchFamily="2" charset="-122"/>
+              <a:latin typeface="Arial" panose="020B0604020202090204" pitchFamily="34" charset="0"/>
+              <a:ea typeface="宋体" pitchFamily="2" charset="-122"/>
               <a:cs typeface="+mn-cs"/>
             </a:endParaRPr>
           </a:p>
@@ -5064,8 +5064,8 @@
               <a:effectLst/>
               <a:uLnTx/>
               <a:uFillTx/>
-              <a:latin typeface="Arial" panose="020B0604020202020204" pitchFamily="34" charset="0"/>
-              <a:ea typeface="宋体" panose="02010600030101010101" pitchFamily="2" charset="-122"/>
+              <a:latin typeface="Arial" panose="020B0604020202090204" pitchFamily="34" charset="0"/>
+              <a:ea typeface="宋体" pitchFamily="2" charset="-122"/>
               <a:cs typeface="+mn-cs"/>
             </a:endParaRPr>
           </a:p>
@@ -5112,8 +5112,8 @@
               <a:effectLst/>
               <a:uLnTx/>
               <a:uFillTx/>
-              <a:latin typeface="Arial" panose="020B0604020202020204" pitchFamily="34" charset="0"/>
-              <a:ea typeface="宋体" panose="02010600030101010101" pitchFamily="2" charset="-122"/>
+              <a:latin typeface="Arial" panose="020B0604020202090204" pitchFamily="34" charset="0"/>
+              <a:ea typeface="宋体" pitchFamily="2" charset="-122"/>
               <a:cs typeface="+mn-cs"/>
             </a:endParaRPr>
           </a:p>
@@ -5161,8 +5161,8 @@
                 <a:effectLst/>
                 <a:uLnTx/>
                 <a:uFillTx/>
-                <a:latin typeface="Arial" panose="020B0604020202020204" pitchFamily="34" charset="0"/>
-                <a:ea typeface="宋体" panose="02010600030101010101" pitchFamily="2" charset="-122"/>
+                <a:latin typeface="Arial" panose="020B0604020202090204" pitchFamily="34" charset="0"/>
+                <a:ea typeface="宋体" pitchFamily="2" charset="-122"/>
                 <a:cs typeface="+mn-cs"/>
               </a:rPr>
             </a:fld>
@@ -5176,8 +5176,8 @@
               <a:effectLst/>
               <a:uLnTx/>
               <a:uFillTx/>
-              <a:latin typeface="Arial" panose="020B0604020202020204" pitchFamily="34" charset="0"/>
-              <a:ea typeface="宋体" panose="02010600030101010101" pitchFamily="2" charset="-122"/>
+              <a:latin typeface="Arial" panose="020B0604020202090204" pitchFamily="34" charset="0"/>
+              <a:ea typeface="宋体" pitchFamily="2" charset="-122"/>
               <a:cs typeface="+mn-cs"/>
             </a:endParaRPr>
           </a:p>
@@ -5463,7 +5463,7 @@
                 <a:solidFill>
                   <a:schemeClr val="tx1"/>
                 </a:solidFill>
-                <a:ea typeface="宋体" panose="02010600030101010101" pitchFamily="2" charset="-122"/>
+                <a:ea typeface="宋体" pitchFamily="2" charset="-122"/>
               </a:defRPr>
             </a:lvl1pPr>
           </a:lstStyle>
@@ -5494,8 +5494,8 @@
               <a:effectLst/>
               <a:uLnTx/>
               <a:uFillTx/>
-              <a:latin typeface="Arial" panose="020B0604020202020204" pitchFamily="34" charset="0"/>
-              <a:ea typeface="宋体" panose="02010600030101010101" pitchFamily="2" charset="-122"/>
+              <a:latin typeface="Arial" panose="020B0604020202090204" pitchFamily="34" charset="0"/>
+              <a:ea typeface="宋体" pitchFamily="2" charset="-122"/>
               <a:cs typeface="+mn-cs"/>
             </a:endParaRPr>
           </a:p>
@@ -5571,7 +5571,7 @@
                 <a:solidFill>
                   <a:schemeClr val="tx1"/>
                 </a:solidFill>
-                <a:ea typeface="宋体" panose="02010600030101010101" pitchFamily="2" charset="-122"/>
+                <a:ea typeface="宋体" pitchFamily="2" charset="-122"/>
               </a:defRPr>
             </a:lvl1pPr>
           </a:lstStyle>
@@ -5602,8 +5602,8 @@
               <a:effectLst/>
               <a:uLnTx/>
               <a:uFillTx/>
-              <a:latin typeface="Arial" panose="020B0604020202020204" pitchFamily="34" charset="0"/>
-              <a:ea typeface="宋体" panose="02010600030101010101" pitchFamily="2" charset="-122"/>
+              <a:latin typeface="Arial" panose="020B0604020202090204" pitchFamily="34" charset="0"/>
+              <a:ea typeface="宋体" pitchFamily="2" charset="-122"/>
               <a:cs typeface="+mn-cs"/>
             </a:endParaRPr>
           </a:p>
@@ -5679,7 +5679,7 @@
                 <a:solidFill>
                   <a:schemeClr val="tx1"/>
                 </a:solidFill>
-                <a:ea typeface="宋体" panose="02010600030101010101" pitchFamily="2" charset="-122"/>
+                <a:ea typeface="宋体" pitchFamily="2" charset="-122"/>
               </a:defRPr>
             </a:lvl1pPr>
           </a:lstStyle>
@@ -5711,8 +5711,8 @@
                 <a:effectLst/>
                 <a:uLnTx/>
                 <a:uFillTx/>
-                <a:latin typeface="Arial" panose="020B0604020202020204" pitchFamily="34" charset="0"/>
-                <a:ea typeface="宋体" panose="02010600030101010101" pitchFamily="2" charset="-122"/>
+                <a:latin typeface="Arial" panose="020B0604020202090204" pitchFamily="34" charset="0"/>
+                <a:ea typeface="宋体" pitchFamily="2" charset="-122"/>
                 <a:cs typeface="+mn-cs"/>
               </a:rPr>
             </a:fld>
@@ -5726,8 +5726,8 @@
               <a:effectLst/>
               <a:uLnTx/>
               <a:uFillTx/>
-              <a:latin typeface="Arial" panose="020B0604020202020204" pitchFamily="34" charset="0"/>
-              <a:ea typeface="宋体" panose="02010600030101010101" pitchFamily="2" charset="-122"/>
+              <a:latin typeface="Arial" panose="020B0604020202090204" pitchFamily="34" charset="0"/>
+              <a:ea typeface="宋体" pitchFamily="2" charset="-122"/>
               <a:cs typeface="+mn-cs"/>
             </a:endParaRPr>
           </a:p>
@@ -5805,7 +5805,7 @@
                 <a:solidFill>
                   <a:srgbClr val="FF3300"/>
                 </a:solidFill>
-                <a:latin typeface="Arial" panose="020B0604020202020204" pitchFamily="34" charset="0"/>
+                <a:latin typeface="Arial" panose="020B0604020202090204" pitchFamily="34" charset="0"/>
                 <a:ea typeface="黑体" panose="02010609060101010101" pitchFamily="49" charset="-122"/>
               </a:defRPr>
             </a:lvl1pPr>
@@ -5825,7 +5825,7 @@
                 <a:solidFill>
                   <a:srgbClr val="FF3300"/>
                 </a:solidFill>
-                <a:latin typeface="Arial" panose="020B0604020202020204" pitchFamily="34" charset="0"/>
+                <a:latin typeface="Arial" panose="020B0604020202090204" pitchFamily="34" charset="0"/>
                 <a:ea typeface="黑体" panose="02010609060101010101" pitchFamily="49" charset="-122"/>
               </a:defRPr>
             </a:lvl2pPr>
@@ -5845,7 +5845,7 @@
                 <a:solidFill>
                   <a:srgbClr val="FF3300"/>
                 </a:solidFill>
-                <a:latin typeface="Arial" panose="020B0604020202020204" pitchFamily="34" charset="0"/>
+                <a:latin typeface="Arial" panose="020B0604020202090204" pitchFamily="34" charset="0"/>
                 <a:ea typeface="黑体" panose="02010609060101010101" pitchFamily="49" charset="-122"/>
               </a:defRPr>
             </a:lvl3pPr>
@@ -5865,7 +5865,7 @@
                 <a:solidFill>
                   <a:srgbClr val="FF3300"/>
                 </a:solidFill>
-                <a:latin typeface="Arial" panose="020B0604020202020204" pitchFamily="34" charset="0"/>
+                <a:latin typeface="Arial" panose="020B0604020202090204" pitchFamily="34" charset="0"/>
                 <a:ea typeface="黑体" panose="02010609060101010101" pitchFamily="49" charset="-122"/>
               </a:defRPr>
             </a:lvl4pPr>
@@ -5885,7 +5885,7 @@
                 <a:solidFill>
                   <a:srgbClr val="FF3300"/>
                 </a:solidFill>
-                <a:latin typeface="Arial" panose="020B0604020202020204" pitchFamily="34" charset="0"/>
+                <a:latin typeface="Arial" panose="020B0604020202090204" pitchFamily="34" charset="0"/>
                 <a:ea typeface="黑体" panose="02010609060101010101" pitchFamily="49" charset="-122"/>
               </a:defRPr>
             </a:lvl5pPr>
@@ -5908,7 +5908,7 @@
                 <a:solidFill>
                   <a:srgbClr val="FF3300"/>
                 </a:solidFill>
-                <a:latin typeface="Arial" panose="020B0604020202020204" pitchFamily="34" charset="0"/>
+                <a:latin typeface="Arial" panose="020B0604020202090204" pitchFamily="34" charset="0"/>
                 <a:ea typeface="黑体" panose="02010609060101010101" pitchFamily="49" charset="-122"/>
               </a:defRPr>
             </a:lvl6pPr>
@@ -5931,7 +5931,7 @@
                 <a:solidFill>
                   <a:srgbClr val="FF3300"/>
                 </a:solidFill>
-                <a:latin typeface="Arial" panose="020B0604020202020204" pitchFamily="34" charset="0"/>
+                <a:latin typeface="Arial" panose="020B0604020202090204" pitchFamily="34" charset="0"/>
                 <a:ea typeface="黑体" panose="02010609060101010101" pitchFamily="49" charset="-122"/>
               </a:defRPr>
             </a:lvl7pPr>
@@ -5954,7 +5954,7 @@
                 <a:solidFill>
                   <a:srgbClr val="FF3300"/>
                 </a:solidFill>
-                <a:latin typeface="Arial" panose="020B0604020202020204" pitchFamily="34" charset="0"/>
+                <a:latin typeface="Arial" panose="020B0604020202090204" pitchFamily="34" charset="0"/>
                 <a:ea typeface="黑体" panose="02010609060101010101" pitchFamily="49" charset="-122"/>
               </a:defRPr>
             </a:lvl8pPr>
@@ -5977,7 +5977,7 @@
                 <a:solidFill>
                   <a:srgbClr val="FF3300"/>
                 </a:solidFill>
-                <a:latin typeface="Arial" panose="020B0604020202020204" pitchFamily="34" charset="0"/>
+                <a:latin typeface="Arial" panose="020B0604020202090204" pitchFamily="34" charset="0"/>
                 <a:ea typeface="黑体" panose="02010609060101010101" pitchFamily="49" charset="-122"/>
               </a:defRPr>
             </a:lvl9pPr>
@@ -6010,7 +6010,7 @@
               <a:uLnTx/>
               <a:uFillTx/>
               <a:latin typeface="Tahoma" panose="020B0604030504040204" pitchFamily="34" charset="0"/>
-              <a:ea typeface="宋体" panose="02010600030101010101" pitchFamily="2" charset="-122"/>
+              <a:ea typeface="宋体" pitchFamily="2" charset="-122"/>
               <a:cs typeface="+mn-cs"/>
             </a:endParaRPr>
           </a:p>
@@ -6249,7 +6249,7 @@
           <a:solidFill>
             <a:schemeClr val="tx1"/>
           </a:solidFill>
-          <a:latin typeface="Arial" panose="020B0604020202020204" pitchFamily="34" charset="0"/>
+          <a:latin typeface="Arial" panose="020B0604020202090204" pitchFamily="34" charset="0"/>
           <a:ea typeface="+mn-ea"/>
           <a:cs typeface="+mn-cs"/>
         </a:defRPr>
@@ -6269,7 +6269,7 @@
           <a:solidFill>
             <a:schemeClr val="tx1"/>
           </a:solidFill>
-          <a:latin typeface="Comic Sans MS" panose="030F0702030302020204" pitchFamily="66" charset="0"/>
+          <a:latin typeface="Comic Sans MS" panose="030F0902030302020204" pitchFamily="66" charset="0"/>
           <a:ea typeface="楷体_GB2312" pitchFamily="49" charset="-122"/>
           <a:cs typeface="+mn-cs"/>
         </a:defRPr>
@@ -6286,8 +6286,8 @@
           <a:solidFill>
             <a:schemeClr val="tx1"/>
           </a:solidFill>
-          <a:latin typeface="Arial" panose="020B0604020202020204" pitchFamily="34" charset="0"/>
-          <a:ea typeface="宋体" panose="02010600030101010101" pitchFamily="2" charset="-122"/>
+          <a:latin typeface="Arial" panose="020B0604020202090204" pitchFamily="34" charset="0"/>
+          <a:ea typeface="宋体" pitchFamily="2" charset="-122"/>
           <a:cs typeface="+mn-cs"/>
         </a:defRPr>
       </a:lvl4pPr>
@@ -6303,8 +6303,8 @@
           <a:solidFill>
             <a:schemeClr val="tx1"/>
           </a:solidFill>
-          <a:latin typeface="Arial" panose="020B0604020202020204" pitchFamily="34" charset="0"/>
-          <a:ea typeface="宋体" panose="02010600030101010101" pitchFamily="2" charset="-122"/>
+          <a:latin typeface="Arial" panose="020B0604020202090204" pitchFamily="34" charset="0"/>
+          <a:ea typeface="宋体" pitchFamily="2" charset="-122"/>
           <a:cs typeface="+mn-cs"/>
         </a:defRPr>
       </a:lvl5pPr>
@@ -6315,7 +6315,7 @@
         <a:spcBef>
           <a:spcPts val="500"/>
         </a:spcBef>
-        <a:buFont typeface="Arial" panose="020B0604020202020204" pitchFamily="34" charset="0"/>
+        <a:buFont typeface="Arial" panose="020B0604020202090204" pitchFamily="34" charset="0"/>
         <a:buChar char="•"/>
         <a:defRPr sz="1800" kern="1200">
           <a:solidFill>
@@ -6333,7 +6333,7 @@
         <a:spcBef>
           <a:spcPts val="500"/>
         </a:spcBef>
-        <a:buFont typeface="Arial" panose="020B0604020202020204" pitchFamily="34" charset="0"/>
+        <a:buFont typeface="Arial" panose="020B0604020202090204" pitchFamily="34" charset="0"/>
         <a:buChar char="•"/>
         <a:defRPr sz="1800" kern="1200">
           <a:solidFill>
@@ -6351,7 +6351,7 @@
         <a:spcBef>
           <a:spcPts val="500"/>
         </a:spcBef>
-        <a:buFont typeface="Arial" panose="020B0604020202020204" pitchFamily="34" charset="0"/>
+        <a:buFont typeface="Arial" panose="020B0604020202090204" pitchFamily="34" charset="0"/>
         <a:buChar char="•"/>
         <a:defRPr sz="1800" kern="1200">
           <a:solidFill>
@@ -6369,7 +6369,7 @@
         <a:spcBef>
           <a:spcPts val="500"/>
         </a:spcBef>
-        <a:buFont typeface="Arial" panose="020B0604020202020204" pitchFamily="34" charset="0"/>
+        <a:buFont typeface="Arial" panose="020B0604020202090204" pitchFamily="34" charset="0"/>
         <a:buChar char="•"/>
         <a:defRPr sz="1800" kern="1200">
           <a:solidFill>
@@ -6514,9 +6514,54 @@
                 <a:latin typeface="微软雅黑" panose="020B0503020204020204" charset="-122"/>
               </a:rPr>
               <a:t>研究方向：Text-to-SQL / SQL+ 中间表示 / 多智能体 / 执行反馈修正
-汇报人：待填写    导师：待填写    时间：待填写</a:t>
-            </a:r>
-            <a:endParaRPr sz="1700" b="0">
+汇报人：</a:t>
+            </a:r>
+            <a:r>
+              <a:rPr lang="zh-CN" sz="1700" b="0">
+                <a:solidFill>
+                  <a:srgbClr val="1F2933"/>
+                </a:solidFill>
+                <a:latin typeface="微软雅黑" panose="020B0503020204020204" charset="-122"/>
+              </a:rPr>
+              <a:t>艾筠舜</a:t>
+            </a:r>
+            <a:r>
+              <a:rPr sz="1700" b="0">
+                <a:solidFill>
+                  <a:srgbClr val="1F2933"/>
+                </a:solidFill>
+                <a:latin typeface="微软雅黑" panose="020B0503020204020204" charset="-122"/>
+              </a:rPr>
+              <a:t>    导师：</a:t>
+            </a:r>
+            <a:r>
+              <a:rPr lang="zh-CN" sz="1700" b="0">
+                <a:solidFill>
+                  <a:srgbClr val="1F2933"/>
+                </a:solidFill>
+                <a:latin typeface="微软雅黑" panose="020B0503020204020204" charset="-122"/>
+              </a:rPr>
+              <a:t>王芳</a:t>
+            </a:r>
+            <a:r>
+              <a:rPr sz="1700" b="0">
+                <a:solidFill>
+                  <a:srgbClr val="1F2933"/>
+                </a:solidFill>
+                <a:latin typeface="微软雅黑" panose="020B0503020204020204" charset="-122"/>
+              </a:rPr>
+              <a:t>    时间：</a:t>
+            </a:r>
+            <a:r>
+              <a:rPr lang="en-US" sz="1700" b="0">
+                <a:solidFill>
+                  <a:srgbClr val="1F2933"/>
+                </a:solidFill>
+                <a:latin typeface="微软雅黑" panose="020B0503020204020204" charset="-122"/>
+              </a:rPr>
+              <a:t>2026.7</a:t>
+            </a:r>
+            <a:endParaRPr lang="en-US" sz="1700" b="0">
               <a:solidFill>
                 <a:srgbClr val="1F2933"/>
               </a:solidFill>
@@ -16025,95 +16070,6 @@
                           </a:solidFill>
                           <a:latin typeface="微软雅黑" panose="020B0503020204020204" charset="-122"/>
                         </a:rPr>
-                        <a:t>结果被误读</a:t>
-                      </a:r>
-                      <a:endParaRPr sz="1200" b="0">
-                        <a:solidFill>
-                          <a:srgbClr val="1F2933"/>
-                        </a:solidFill>
-                        <a:latin typeface="微软雅黑" panose="020B0503020204020204" charset="-122"/>
-                      </a:endParaRPr>
-                    </a:p>
-                  </a:txBody>
-                  <a:tcPr marL="36576" marR="36576">
-                    <a:solidFill>
-                      <a:srgbClr val="F6F8FA"/>
-                    </a:solidFill>
-                  </a:tcPr>
-                </a:tc>
-                <a:tc>
-                  <a:txBody>
-                    <a:bodyPr/>
-                    <a:lstStyle/>
-                    <a:p>
-                      <a:pPr algn="ctr"/>
-                      <a:r>
-                        <a:rPr sz="1200" b="0">
-                          <a:solidFill>
-                            <a:srgbClr val="1F2933"/>
-                          </a:solidFill>
-                          <a:latin typeface="微软雅黑" panose="020B0503020204020204" charset="-122"/>
-                        </a:rPr>
-                        <a:t>conversion smoke 来自 gold SQL</a:t>
-                      </a:r>
-                      <a:endParaRPr sz="1200" b="0">
-                        <a:solidFill>
-                          <a:srgbClr val="1F2933"/>
-                        </a:solidFill>
-                        <a:latin typeface="微软雅黑" panose="020B0503020204020204" charset="-122"/>
-                      </a:endParaRPr>
-                    </a:p>
-                  </a:txBody>
-                  <a:tcPr marL="36576" marR="36576">
-                    <a:solidFill>
-                      <a:srgbClr val="F6F8FA"/>
-                    </a:solidFill>
-                  </a:tcPr>
-                </a:tc>
-                <a:tc>
-                  <a:txBody>
-                    <a:bodyPr/>
-                    <a:lstStyle/>
-                    <a:p>
-                      <a:pPr algn="ctr"/>
-                      <a:r>
-                        <a:rPr sz="1200" b="0">
-                          <a:solidFill>
-                            <a:srgbClr val="1F2933"/>
-                          </a:solidFill>
-                          <a:latin typeface="微软雅黑" panose="020B0503020204020204" charset="-122"/>
-                        </a:rPr>
-                        <a:t>PPT 和论文中始终标注边界</a:t>
-                      </a:r>
-                      <a:endParaRPr sz="1200" b="0">
-                        <a:solidFill>
-                          <a:srgbClr val="1F2933"/>
-                        </a:solidFill>
-                        <a:latin typeface="微软雅黑" panose="020B0503020204020204" charset="-122"/>
-                      </a:endParaRPr>
-                    </a:p>
-                  </a:txBody>
-                  <a:tcPr marL="36576" marR="36576">
-                    <a:solidFill>
-                      <a:srgbClr val="F6F8FA"/>
-                    </a:solidFill>
-                  </a:tcPr>
-                </a:tc>
-              </a:tr>
-              <a:tr h="397510">
-                <a:tc>
-                  <a:txBody>
-                    <a:bodyPr/>
-                    <a:lstStyle/>
-                    <a:p>
-                      <a:pPr algn="ctr"/>
-                      <a:r>
-                        <a:rPr sz="1200" b="0">
-                          <a:solidFill>
-                            <a:srgbClr val="1F2933"/>
-                          </a:solidFill>
-                          <a:latin typeface="微软雅黑" panose="020B0503020204020204" charset="-122"/>
-                        </a:rPr>
                         <a:t>SQL+ 成本较高</a:t>
                       </a:r>
                       <a:endParaRPr sz="1200" b="0">
@@ -16290,7 +16246,7 @@
         </p:nvSpPr>
         <p:spPr>
           <a:xfrm>
-            <a:off x="685800" y="4436745"/>
+            <a:off x="685800" y="4077335"/>
             <a:ext cx="1600200" cy="438912"/>
           </a:xfrm>
           <a:prstGeom prst="rect">
@@ -16325,13 +16281,31 @@
           <a:p>
             <a:pPr algn="ctr"/>
             <a:r>
-              <a:rPr sz="1100" b="1">
+              <a:rPr lang="en-US" sz="1100" b="1">
                 <a:solidFill>
                   <a:srgbClr val="FFFFFF"/>
                 </a:solidFill>
                 <a:latin typeface="微软雅黑" panose="020B0503020204020204" charset="-122"/>
               </a:rPr>
-              <a:t>07-08</a:t>
+              <a:t>2026.</a:t>
+            </a:r>
+            <a:r>
+              <a:rPr sz="1100" b="1">
+                <a:solidFill>
+                  <a:srgbClr val="FFFFFF"/>
+                </a:solidFill>
+                <a:latin typeface="微软雅黑" panose="020B0503020204020204" charset="-122"/>
+              </a:rPr>
+              <a:t>7-</a:t>
+            </a:r>
+            <a:r>
+              <a:rPr lang="en-US" sz="1100" b="1">
+                <a:solidFill>
+                  <a:srgbClr val="FFFFFF"/>
+                </a:solidFill>
+                <a:latin typeface="微软雅黑" panose="020B0503020204020204" charset="-122"/>
+              </a:rPr>
+              <a:t>2026.10</a:t>
             </a:r>
             <a:endParaRPr sz="1100" b="1">
               <a:solidFill>
@@ -16350,7 +16324,7 @@
         </p:nvSpPr>
         <p:spPr>
           <a:xfrm>
-            <a:off x="685800" y="4921377"/>
+            <a:off x="685800" y="4561967"/>
             <a:ext cx="1600200" cy="731520"/>
           </a:xfrm>
           <a:prstGeom prst="rect">
@@ -16411,7 +16385,7 @@
         </p:nvSpPr>
         <p:spPr>
           <a:xfrm>
-            <a:off x="2697480" y="4436745"/>
+            <a:off x="2697480" y="4077335"/>
             <a:ext cx="1600200" cy="438912"/>
           </a:xfrm>
           <a:prstGeom prst="rect">
@@ -16446,15 +16420,33 @@
           <a:p>
             <a:pPr algn="ctr"/>
             <a:r>
-              <a:rPr sz="1100" b="1">
+              <a:rPr lang="en-US" sz="1100" b="1">
                 <a:solidFill>
                   <a:srgbClr val="FFFFFF"/>
                 </a:solidFill>
                 <a:latin typeface="微软雅黑" panose="020B0503020204020204" charset="-122"/>
               </a:rPr>
-              <a:t>09-10</a:t>
-            </a:r>
-            <a:endParaRPr sz="1100" b="1">
+              <a:t>2026.10</a:t>
+            </a:r>
+            <a:r>
+              <a:rPr sz="1100" b="1">
+                <a:solidFill>
+                  <a:srgbClr val="FFFFFF"/>
+                </a:solidFill>
+                <a:latin typeface="微软雅黑" panose="020B0503020204020204" charset="-122"/>
+              </a:rPr>
+              <a:t>-</a:t>
+            </a:r>
+            <a:r>
+              <a:rPr lang="en-US" sz="1100" b="1">
+                <a:solidFill>
+                  <a:srgbClr val="FFFFFF"/>
+                </a:solidFill>
+                <a:latin typeface="微软雅黑" panose="020B0503020204020204" charset="-122"/>
+              </a:rPr>
+              <a:t>2027.1</a:t>
+            </a:r>
+            <a:endParaRPr lang="en-US" sz="1100" b="1">
               <a:solidFill>
                 <a:srgbClr val="FFFFFF"/>
               </a:solidFill>
@@ -16471,7 +16463,7 @@
         </p:nvSpPr>
         <p:spPr>
           <a:xfrm>
-            <a:off x="2697480" y="4921377"/>
+            <a:off x="2697480" y="4561967"/>
             <a:ext cx="1600200" cy="731520"/>
           </a:xfrm>
           <a:prstGeom prst="rect">
@@ -16532,7 +16524,7 @@
         </p:nvSpPr>
         <p:spPr>
           <a:xfrm>
-            <a:off x="4709160" y="4436745"/>
+            <a:off x="4709160" y="4077335"/>
             <a:ext cx="1600200" cy="438912"/>
           </a:xfrm>
           <a:prstGeom prst="rect">
@@ -16567,13 +16559,13 @@
           <a:p>
             <a:pPr algn="ctr"/>
             <a:r>
-              <a:rPr sz="1100" b="1">
+              <a:rPr lang="en-US" sz="1100" b="1">
                 <a:solidFill>
                   <a:srgbClr val="FFFFFF"/>
                 </a:solidFill>
                 <a:latin typeface="微软雅黑" panose="020B0503020204020204" charset="-122"/>
               </a:rPr>
-              <a:t>11-12</a:t>
+              <a:t>2027.1-2027.5</a:t>
             </a:r>
             <a:endParaRPr sz="1100" b="1">
               <a:solidFill>
@@ -16592,7 +16584,7 @@
         </p:nvSpPr>
         <p:spPr>
           <a:xfrm>
-            <a:off x="4709160" y="4921377"/>
+            <a:off x="4709160" y="4561967"/>
             <a:ext cx="1600200" cy="731520"/>
           </a:xfrm>
           <a:prstGeom prst="rect">
@@ -16653,7 +16645,7 @@
         </p:nvSpPr>
         <p:spPr>
           <a:xfrm>
-            <a:off x="6720840" y="4436745"/>
+            <a:off x="6720840" y="4077335"/>
             <a:ext cx="1600200" cy="438912"/>
           </a:xfrm>
           <a:prstGeom prst="rect">
@@ -16713,7 +16705,7 @@
         </p:nvSpPr>
         <p:spPr>
           <a:xfrm>
-            <a:off x="6720840" y="4921377"/>
+            <a:off x="6720840" y="4561967"/>
             <a:ext cx="1600200" cy="731520"/>
           </a:xfrm>
           <a:prstGeom prst="rect">
@@ -19149,8 +19141,8 @@
         </p:nvSpPr>
         <p:spPr>
           <a:xfrm>
-            <a:off x="667512" y="3433255"/>
-            <a:ext cx="1545336" cy="1143635"/>
+            <a:off x="667512" y="3353880"/>
+            <a:ext cx="1545336" cy="1302385"/>
           </a:xfrm>
           <a:prstGeom prst="rect">
             <a:avLst/>
@@ -19171,7 +19163,61 @@
                 </a:solidFill>
                 <a:latin typeface="微软雅黑" panose="020B0503020204020204" charset="-122"/>
               </a:rPr>
-              <a:t>Spider 定义跨数据库复杂 SQL 任务；BIRD 引入真实数据库、外部知识和效率要求。
+              <a:t>Spider</a:t>
+            </a:r>
+            <a:r>
+              <a:rPr lang="en-US" sz="1030" b="0">
+                <a:solidFill>
+                  <a:srgbClr val="1F2933"/>
+                </a:solidFill>
+                <a:latin typeface="微软雅黑" panose="020B0503020204020204" charset="-122"/>
+              </a:rPr>
+              <a:t>(</a:t>
+            </a:r>
+            <a:r>
+              <a:rPr lang="en-US" altLang="en-US" sz="1030" b="0">
+                <a:solidFill>
+                  <a:srgbClr val="1F2933"/>
+                </a:solidFill>
+                <a:latin typeface="微软雅黑" panose="020B0503020204020204" charset="-122"/>
+              </a:rPr>
+              <a:t>EMNLP 2018)</a:t>
+            </a:r>
+            <a:r>
+              <a:rPr sz="1030" b="0">
+                <a:solidFill>
+                  <a:srgbClr val="1F2933"/>
+                </a:solidFill>
+                <a:latin typeface="微软雅黑" panose="020B0503020204020204" charset="-122"/>
+              </a:rPr>
+              <a:t> 定义跨数据库复杂 SQL 任务；BIRD</a:t>
+            </a:r>
+            <a:r>
+              <a:rPr lang="en-US" sz="1030" b="0">
+                <a:solidFill>
+                  <a:srgbClr val="1F2933"/>
+                </a:solidFill>
+                <a:latin typeface="微软雅黑" panose="020B0503020204020204" charset="-122"/>
+              </a:rPr>
+              <a:t>(</a:t>
+            </a:r>
+            <a:r>
+              <a:rPr lang="en-US" altLang="en-US" sz="1030" b="0">
+                <a:solidFill>
+                  <a:srgbClr val="1F2933"/>
+                </a:solidFill>
+                <a:latin typeface="微软雅黑" panose="020B0503020204020204" charset="-122"/>
+              </a:rPr>
+              <a:t>NeurIPS 2023)</a:t>
+            </a:r>
+            <a:r>
+              <a:rPr sz="1030" b="0">
+                <a:solidFill>
+                  <a:srgbClr val="1F2933"/>
+                </a:solidFill>
+                <a:latin typeface="微软雅黑" panose="020B0503020204020204" charset="-122"/>
+              </a:rPr>
+              <a:t> 引入真实数据库、外部知识和效率要求。
 启发：评价不能只看语法，还要看执行一致、效率和复杂查询表现。</a:t>
             </a:r>
             <a:endParaRPr sz="1030" b="0">
@@ -19381,8 +19427,8 @@
         </p:nvSpPr>
         <p:spPr>
           <a:xfrm>
-            <a:off x="2743200" y="3353880"/>
-            <a:ext cx="1545336" cy="1302385"/>
+            <a:off x="2743200" y="3116390"/>
+            <a:ext cx="1545336" cy="1777365"/>
           </a:xfrm>
           <a:prstGeom prst="rect">
             <a:avLst/>
@@ -19403,7 +19449,115 @@
                 </a:solidFill>
                 <a:latin typeface="微软雅黑" panose="020B0503020204020204" charset="-122"/>
               </a:rPr>
-              <a:t>IRNet/SemQL、RAT-SQL、NatSQL、PICARD 分别从语义表示、schema linking、简化表达和约束解码降低生成难度。
+              <a:t>IRNet/SemQL</a:t>
+            </a:r>
+            <a:r>
+              <a:rPr lang="en-US" sz="1030" b="0">
+                <a:solidFill>
+                  <a:srgbClr val="1F2933"/>
+                </a:solidFill>
+                <a:latin typeface="微软雅黑" panose="020B0503020204020204" charset="-122"/>
+              </a:rPr>
+              <a:t>(</a:t>
+            </a:r>
+            <a:r>
+              <a:rPr lang="en-US" altLang="en-US" sz="1030" b="0">
+                <a:solidFill>
+                  <a:srgbClr val="1F2933"/>
+                </a:solidFill>
+                <a:latin typeface="微软雅黑" panose="020B0503020204020204" charset="-122"/>
+              </a:rPr>
+              <a:t>ACL 2019)</a:t>
+            </a:r>
+            <a:r>
+              <a:rPr sz="1030" b="0">
+                <a:solidFill>
+                  <a:srgbClr val="1F2933"/>
+                </a:solidFill>
+                <a:latin typeface="微软雅黑" panose="020B0503020204020204" charset="-122"/>
+              </a:rPr>
+              <a:t>、RAT-SQL</a:t>
+            </a:r>
+            <a:r>
+              <a:rPr lang="en-US" sz="1030" b="0">
+                <a:solidFill>
+                  <a:srgbClr val="1F2933"/>
+                </a:solidFill>
+                <a:latin typeface="微软雅黑" panose="020B0503020204020204" charset="-122"/>
+              </a:rPr>
+              <a:t>(</a:t>
+            </a:r>
+            <a:r>
+              <a:rPr lang="en-US" altLang="en-US" sz="1030" b="0">
+                <a:solidFill>
+                  <a:srgbClr val="1F2933"/>
+                </a:solidFill>
+                <a:latin typeface="微软雅黑" panose="020B0503020204020204" charset="-122"/>
+              </a:rPr>
+              <a:t>ACL 2020)</a:t>
+            </a:r>
+            <a:r>
+              <a:rPr sz="1030" b="0">
+                <a:solidFill>
+                  <a:srgbClr val="1F2933"/>
+                </a:solidFill>
+                <a:latin typeface="微软雅黑" panose="020B0503020204020204" charset="-122"/>
+              </a:rPr>
+              <a:t>、NatSQL</a:t>
+            </a:r>
+            <a:r>
+              <a:rPr lang="en-US" sz="1030" b="0">
+                <a:solidFill>
+                  <a:srgbClr val="1F2933"/>
+                </a:solidFill>
+                <a:latin typeface="微软雅黑" panose="020B0503020204020204" charset="-122"/>
+              </a:rPr>
+              <a:t>(</a:t>
+            </a:r>
+            <a:r>
+              <a:rPr lang="en-US" altLang="en-US" sz="1030" b="0">
+                <a:solidFill>
+                  <a:srgbClr val="1F2933"/>
+                </a:solidFill>
+                <a:latin typeface="微软雅黑" panose="020B0503020204020204" charset="-122"/>
+              </a:rPr>
+              <a:t>EMNLP 2021)</a:t>
+            </a:r>
+            <a:r>
+              <a:rPr sz="1030" b="0">
+                <a:solidFill>
+                  <a:srgbClr val="1F2933"/>
+                </a:solidFill>
+                <a:latin typeface="微软雅黑" panose="020B0503020204020204" charset="-122"/>
+              </a:rPr>
+              <a:t>、PICARD</a:t>
+            </a:r>
+            <a:r>
+              <a:rPr lang="en-US" sz="1030" b="0">
+                <a:solidFill>
+                  <a:srgbClr val="1F2933"/>
+                </a:solidFill>
+                <a:latin typeface="微软雅黑" panose="020B0503020204020204" charset="-122"/>
+              </a:rPr>
+              <a:t>(</a:t>
+            </a:r>
+            <a:r>
+              <a:rPr lang="en-US" altLang="en-US" sz="1030" b="0">
+                <a:solidFill>
+                  <a:srgbClr val="1F2933"/>
+                </a:solidFill>
+                <a:latin typeface="微软雅黑" panose="020B0503020204020204" charset="-122"/>
+              </a:rPr>
+              <a:t>EMNLP 2021)</a:t>
+            </a:r>
+            <a:r>
+              <a:rPr sz="1030" b="0">
+                <a:solidFill>
+                  <a:srgbClr val="1F2933"/>
+                </a:solidFill>
+                <a:latin typeface="微软雅黑" panose="020B0503020204020204" charset="-122"/>
+              </a:rPr>
+              <a:t> 分别从语义表示、schema linking、简化表达和约束解码降低生成难度。
 启发：SQL+ 要体现线性、可转换、可局部修复。</a:t>
             </a:r>
             <a:endParaRPr sz="1030" b="0">
@@ -19635,7 +19789,61 @@
                 </a:solidFill>
                 <a:latin typeface="微软雅黑" panose="020B0503020204020204" charset="-122"/>
               </a:rPr>
-              <a:t>Pipe Syntax 说明 SQL 可通过线性扩展提升可读性；DIN-SQL、LEVER 强调任务分解和执行验证。
+              <a:t>Pipe Syntax 说明 SQL 可通过线性扩展提升可读性；DIN-SQL</a:t>
+            </a:r>
+            <a:r>
+              <a:rPr lang="en-US" sz="1030" b="0">
+                <a:solidFill>
+                  <a:srgbClr val="1F2933"/>
+                </a:solidFill>
+                <a:latin typeface="微软雅黑" panose="020B0503020204020204" charset="-122"/>
+              </a:rPr>
+              <a:t>(</a:t>
+            </a:r>
+            <a:r>
+              <a:rPr lang="en-US" altLang="en-US" sz="1030" b="0">
+                <a:solidFill>
+                  <a:srgbClr val="1F2933"/>
+                </a:solidFill>
+                <a:latin typeface="微软雅黑" panose="020B0503020204020204" charset="-122"/>
+              </a:rPr>
+              <a:t>NeurIPS 2023)</a:t>
+            </a:r>
+            <a:r>
+              <a:rPr sz="1030" b="0">
+                <a:solidFill>
+                  <a:srgbClr val="1F2933"/>
+                </a:solidFill>
+                <a:latin typeface="微软雅黑" panose="020B0503020204020204" charset="-122"/>
+              </a:rPr>
+              <a:t>、LEVER</a:t>
+            </a:r>
+            <a:r>
+              <a:rPr lang="en-US" sz="1030" b="0">
+                <a:solidFill>
+                  <a:srgbClr val="1F2933"/>
+                </a:solidFill>
+                <a:latin typeface="微软雅黑" panose="020B0503020204020204" charset="-122"/>
+              </a:rPr>
+              <a:t>(</a:t>
+            </a:r>
+            <a:r>
+              <a:rPr lang="en-US" altLang="en-US" sz="1030" b="0">
+                <a:solidFill>
+                  <a:srgbClr val="1F2933"/>
+                </a:solidFill>
+                <a:latin typeface="微软雅黑" panose="020B0503020204020204" charset="-122"/>
+              </a:rPr>
+              <a:t>ICML 2023)</a:t>
+            </a:r>
+            <a:r>
+              <a:rPr sz="1030" b="0">
+                <a:solidFill>
+                  <a:srgbClr val="1F2933"/>
+                </a:solidFill>
+                <a:latin typeface="微软雅黑" panose="020B0503020204020204" charset="-122"/>
+              </a:rPr>
+              <a:t> 强调任务分解和执行验证。
 启发：SQL+ 可作为执行反馈回流的步骤化中间层。</a:t>
             </a:r>
             <a:endParaRPr sz="1030" b="0">
@@ -19845,8 +20053,8 @@
         </p:nvSpPr>
         <p:spPr>
           <a:xfrm>
-            <a:off x="6894576" y="3274822"/>
-            <a:ext cx="1545336" cy="1460500"/>
+            <a:off x="6894576" y="3116390"/>
+            <a:ext cx="1545336" cy="1777365"/>
           </a:xfrm>
           <a:prstGeom prst="rect">
             <a:avLst/>
@@ -19867,7 +20075,88 @@
                 </a:solidFill>
                 <a:latin typeface="微软雅黑" panose="020B0503020204020204" charset="-122"/>
               </a:rPr>
-              <a:t>CHESS、CHASE-SQL、MAC-SQL、SQL-Factory、Spider 2.0 强调检索、规划、候选生成、选择和验证。
+              <a:t>CHESS</a:t>
+            </a:r>
+            <a:r>
+              <a:rPr lang="en-US" sz="1030" b="0">
+                <a:solidFill>
+                  <a:srgbClr val="1F2933"/>
+                </a:solidFill>
+                <a:latin typeface="微软雅黑" panose="020B0503020204020204" charset="-122"/>
+              </a:rPr>
+              <a:t>(</a:t>
+            </a:r>
+            <a:r>
+              <a:rPr lang="en-US" altLang="en-US" sz="1030" b="0">
+                <a:solidFill>
+                  <a:srgbClr val="1F2933"/>
+                </a:solidFill>
+                <a:latin typeface="微软雅黑" panose="020B0503020204020204" charset="-122"/>
+              </a:rPr>
+              <a:t>arXiv 2024)</a:t>
+            </a:r>
+            <a:r>
+              <a:rPr sz="1030" b="0">
+                <a:solidFill>
+                  <a:srgbClr val="1F2933"/>
+                </a:solidFill>
+                <a:latin typeface="微软雅黑" panose="020B0503020204020204" charset="-122"/>
+              </a:rPr>
+              <a:t>、CHASE-SQL</a:t>
+            </a:r>
+            <a:r>
+              <a:rPr lang="en-US" sz="1030" b="0">
+                <a:solidFill>
+                  <a:srgbClr val="1F2933"/>
+                </a:solidFill>
+                <a:latin typeface="微软雅黑" panose="020B0503020204020204" charset="-122"/>
+              </a:rPr>
+              <a:t>(</a:t>
+            </a:r>
+            <a:r>
+              <a:rPr lang="en-US" altLang="en-US" sz="1030" b="0">
+                <a:solidFill>
+                  <a:srgbClr val="1F2933"/>
+                </a:solidFill>
+                <a:latin typeface="微软雅黑" panose="020B0503020204020204" charset="-122"/>
+              </a:rPr>
+              <a:t>arXiv 2024)</a:t>
+            </a:r>
+            <a:r>
+              <a:rPr sz="1030" b="0">
+                <a:solidFill>
+                  <a:srgbClr val="1F2933"/>
+                </a:solidFill>
+                <a:latin typeface="微软雅黑" panose="020B0503020204020204" charset="-122"/>
+              </a:rPr>
+              <a:t>、MAC-SQL</a:t>
+            </a:r>
+            <a:r>
+              <a:rPr lang="en-US" sz="1030" b="0">
+                <a:solidFill>
+                  <a:srgbClr val="1F2933"/>
+                </a:solidFill>
+                <a:latin typeface="微软雅黑" panose="020B0503020204020204" charset="-122"/>
+              </a:rPr>
+              <a:t>(</a:t>
+            </a:r>
+            <a:r>
+              <a:rPr lang="en-US" altLang="en-US" sz="1030" b="0">
+                <a:solidFill>
+                  <a:srgbClr val="1F2933"/>
+                </a:solidFill>
+                <a:latin typeface="微软雅黑" panose="020B0503020204020204" charset="-122"/>
+              </a:rPr>
+              <a:t>arXiv 2023)</a:t>
+            </a:r>
+            <a:r>
+              <a:rPr sz="1030" b="0">
+                <a:solidFill>
+                  <a:srgbClr val="1F2933"/>
+                </a:solidFill>
+                <a:latin typeface="微软雅黑" panose="020B0503020204020204" charset="-122"/>
+              </a:rPr>
+              <a:t>、SQL-Factory、Spider 2.0 强调检索、规划、候选生成、选择和验证。
 启发：本课题把多 Agent 落到 Critic、Router、Repair Skill 的可修复闭环。</a:t>
             </a:r>
             <a:endParaRPr sz="1030" b="0">
@@ -23191,7 +23480,7 @@
               <a:srgbClr val="FF3300"/>
             </a:solidFill>
             <a:effectLst/>
-            <a:latin typeface="Arial" panose="020B0604020202020204" pitchFamily="34" charset="0"/>
+            <a:latin typeface="Arial" panose="020B0604020202090204" pitchFamily="34" charset="0"/>
             <a:ea typeface="黑体" panose="02010609060101010101" pitchFamily="49" charset="-122"/>
           </a:defRPr>
         </a:defPPr>
@@ -23251,7 +23540,7 @@
               <a:srgbClr val="FF3300"/>
             </a:solidFill>
             <a:effectLst/>
-            <a:latin typeface="Arial" panose="020B0604020202020204" pitchFamily="34" charset="0"/>
+            <a:latin typeface="Arial" panose="020B0604020202090204" pitchFamily="34" charset="0"/>
             <a:ea typeface="黑体" panose="02010609060101010101" pitchFamily="49" charset="-122"/>
           </a:defRPr>
         </a:defPPr>

</xml_diff>